<commit_message>
Finished setting up all the problem and implementing most of the methods
Most of the methods have been finished, still need to make kruskal's and
prim's algorithms and whatever else i missed
</commit_message>
<xml_diff>
--- a/AssignmentRelatedDocuments/WhatWasSubmitted/Graph Lab.pptx
+++ b/AssignmentRelatedDocuments/WhatWasSubmitted/Graph Lab.pptx
@@ -3746,25 +3746,25 @@
           <p:nvPr>
             <p:extLst>
               <p:ext uri="{D42A27DB-BD31-4B8C-83A1-F6EECF244321}">
-                <p14:modId xmlns:p14="http://schemas.microsoft.com/office/powerpoint/2010/main" val="1262824619"/>
+                <p14:modId xmlns:p14="http://schemas.microsoft.com/office/powerpoint/2010/main" val="2544639646"/>
               </p:ext>
             </p:extLst>
           </p:nvPr>
         </p:nvGraphicFramePr>
         <p:xfrm>
-          <a:off x="538163" y="5110163"/>
-          <a:ext cx="5468937" cy="2438400"/>
+          <a:off x="533400" y="5103813"/>
+          <a:ext cx="5422900" cy="2443162"/>
         </p:xfrm>
         <a:graphic>
           <a:graphicData uri="http://schemas.openxmlformats.org/presentationml/2006/ole">
             <mc:AlternateContent xmlns:mc="http://schemas.openxmlformats.org/markup-compatibility/2006">
               <mc:Choice xmlns:v="urn:schemas-microsoft-com:vml" Requires="v">
-                <p:oleObj spid="_x0000_s2060" name="Document" r:id="rId3" imgW="5491805" imgH="2460978" progId="Word.Document.8">
+                <p:oleObj name="Document" r:id="rId2" imgW="5483860" imgH="2476746" progId="Word.Document.8">
                   <p:embed/>
                 </p:oleObj>
               </mc:Choice>
               <mc:Fallback>
-                <p:oleObj name="Document" r:id="rId3" imgW="5491805" imgH="2460978" progId="Word.Document.8">
+                <p:oleObj name="Document" r:id="rId2" imgW="5483860" imgH="2476746" progId="Word.Document.8">
                   <p:embed/>
                   <p:pic>
                     <p:nvPicPr>
@@ -3775,7 +3775,7 @@
                       <p:nvPr/>
                     </p:nvPicPr>
                     <p:blipFill>
-                      <a:blip r:embed="rId4"/>
+                      <a:blip r:embed="rId3"/>
                       <a:srcRect/>
                       <a:stretch>
                         <a:fillRect/>
@@ -3783,8 +3783,8 @@
                     </p:blipFill>
                     <p:spPr bwMode="auto">
                       <a:xfrm>
-                        <a:off x="538163" y="5110163"/>
-                        <a:ext cx="5468937" cy="2438400"/>
+                        <a:off x="533400" y="5103813"/>
+                        <a:ext cx="5422900" cy="2443162"/>
                       </a:xfrm>
                       <a:prstGeom prst="rect">
                         <a:avLst/>
@@ -4056,8 +4056,8 @@
         </p:nvSpPr>
         <p:spPr bwMode="auto">
           <a:xfrm>
-            <a:off x="338138" y="1189038"/>
-            <a:ext cx="6291262" cy="822325"/>
+            <a:off x="338138" y="1277035"/>
+            <a:ext cx="6291262" cy="646331"/>
           </a:xfrm>
           <a:prstGeom prst="rect">
             <a:avLst/>
@@ -4437,8 +4437,24 @@
               <a:buNone/>
             </a:pPr>
             <a:r>
-              <a:rPr lang="en-US" altLang="en-US" sz="1200"/>
-              <a:t>V(StateGraph) = {Oregon, Alaska, Texas, Hawaii, Vermont, NewYork, California}</a:t>
+              <a:rPr lang="en-US" altLang="en-US" sz="1200" dirty="0"/>
+              <a:t>V(</a:t>
+            </a:r>
+            <a:r>
+              <a:rPr lang="en-US" altLang="en-US" sz="1200" dirty="0" err="1"/>
+              <a:t>StateGraph</a:t>
+            </a:r>
+            <a:r>
+              <a:rPr lang="en-US" altLang="en-US" sz="1200" dirty="0"/>
+              <a:t>) = {Oregon, Alaska, Texas, Hawaii, Vermont, </a:t>
+            </a:r>
+            <a:r>
+              <a:rPr lang="en-US" altLang="en-US" sz="1200" dirty="0" err="1"/>
+              <a:t>NewYork</a:t>
+            </a:r>
+            <a:r>
+              <a:rPr lang="en-US" altLang="en-US" sz="1200" dirty="0"/>
+              <a:t>, California}</a:t>
             </a:r>
           </a:p>
           <a:p>
@@ -4450,8 +4466,16 @@
               <a:buNone/>
             </a:pPr>
             <a:r>
-              <a:rPr lang="en-US" altLang="en-US" sz="1200"/>
-              <a:t>E(StateGraph) = {(Alaska, Oregon), (Hawaii, Alaska), (Hawaii, Texas), (Texas, Hawaii), (Hawaii, 	California), (Hawaii, New York), (Texas, Vermont), (Vermont, California), 	(Vermont, Alaska)}</a:t>
+              <a:rPr lang="en-US" altLang="en-US" sz="1200" dirty="0"/>
+              <a:t>E(</a:t>
+            </a:r>
+            <a:r>
+              <a:rPr lang="en-US" altLang="en-US" sz="1200" dirty="0" err="1"/>
+              <a:t>StateGraph</a:t>
+            </a:r>
+            <a:r>
+              <a:rPr lang="en-US" altLang="en-US" sz="1200" dirty="0"/>
+              <a:t>) = {(Alaska, Oregon), (Hawaii, Alaska), (Hawaii, Texas), (Texas, Hawaii), (Hawaii, 	California), (Hawaii, New York), (Texas, Vermont), (Vermont, California), (Vermont, Alaska)}</a:t>
             </a:r>
           </a:p>
         </p:txBody>
@@ -5937,8 +5961,8 @@
         </p:nvSpPr>
         <p:spPr bwMode="auto">
           <a:xfrm>
-            <a:off x="228600" y="3248025"/>
-            <a:ext cx="5653088" cy="1370013"/>
+            <a:off x="233973" y="2895600"/>
+            <a:ext cx="5704254" cy="2308324"/>
           </a:xfrm>
           <a:prstGeom prst="rect">
             <a:avLst/>
@@ -6400,6 +6424,65 @@
               <a:t>	D)	E, C, F, B, A, D, G </a:t>
             </a:r>
           </a:p>
+          <a:p>
+            <a:pPr>
+              <a:spcBef>
+                <a:spcPct val="0"/>
+              </a:spcBef>
+              <a:buFontTx/>
+              <a:buNone/>
+            </a:pPr>
+            <a:endParaRPr lang="en-US" altLang="en-US" sz="1200" dirty="0"/>
+          </a:p>
+          <a:p>
+            <a:pPr>
+              <a:spcBef>
+                <a:spcPct val="0"/>
+              </a:spcBef>
+              <a:buFontTx/>
+              <a:buNone/>
+            </a:pPr>
+            <a:r>
+              <a:rPr lang="en-US" altLang="en-US" sz="1200" dirty="0"/>
+              <a:t>When there is a choice between options, I do alphabetical order, </a:t>
+            </a:r>
+          </a:p>
+          <a:p>
+            <a:pPr>
+              <a:spcBef>
+                <a:spcPct val="0"/>
+              </a:spcBef>
+              <a:buFontTx/>
+              <a:buNone/>
+            </a:pPr>
+            <a:r>
+              <a:rPr lang="en-US" altLang="en-US" sz="1200" dirty="0"/>
+              <a:t>but that leads to none of the options, so I’ll do reverse alphabetical order to get option A</a:t>
+            </a:r>
+          </a:p>
+          <a:p>
+            <a:pPr>
+              <a:spcBef>
+                <a:spcPct val="0"/>
+              </a:spcBef>
+              <a:buFontTx/>
+              <a:buNone/>
+            </a:pPr>
+            <a:endParaRPr lang="en-US" altLang="en-US" sz="1200" dirty="0"/>
+          </a:p>
+          <a:p>
+            <a:pPr>
+              <a:spcBef>
+                <a:spcPct val="0"/>
+              </a:spcBef>
+              <a:buFontTx/>
+              <a:buNone/>
+            </a:pPr>
+            <a:r>
+              <a:rPr lang="en-US" altLang="en-US" sz="1200" dirty="0"/>
+              <a:t>ANSWER: A</a:t>
+            </a:r>
+          </a:p>
         </p:txBody>
       </p:sp>
       <p:sp>
@@ -6418,8 +6501,8 @@
         </p:nvSpPr>
         <p:spPr bwMode="auto">
           <a:xfrm>
-            <a:off x="228600" y="4800600"/>
-            <a:ext cx="5715000" cy="1004888"/>
+            <a:off x="228600" y="5876206"/>
+            <a:ext cx="5715000" cy="1938992"/>
           </a:xfrm>
           <a:prstGeom prst="rect">
             <a:avLst/>
@@ -6583,7 +6666,7 @@
               <a:buNone/>
             </a:pPr>
             <a:r>
-              <a:rPr lang="en-US" altLang="en-US" sz="1200"/>
+              <a:rPr lang="en-US" altLang="en-US" sz="1200" dirty="0"/>
               <a:t>4 b.    Which of the following lists the graph nodes in breadth first order beginning at F? </a:t>
             </a:r>
           </a:p>
@@ -6596,7 +6679,7 @@
               <a:buNone/>
             </a:pPr>
             <a:r>
-              <a:rPr lang="en-US" altLang="en-US" sz="1200"/>
+              <a:rPr lang="en-US" altLang="en-US" sz="1200" dirty="0"/>
               <a:t>	A)  F, C, D, A, B, E, G</a:t>
             </a:r>
           </a:p>
@@ -6609,7 +6692,7 @@
               <a:buNone/>
             </a:pPr>
             <a:r>
-              <a:rPr lang="en-US" altLang="en-US" sz="1200"/>
+              <a:rPr lang="en-US" altLang="en-US" sz="1200" dirty="0"/>
               <a:t>	B)  F, D, C, A, B, C, G </a:t>
             </a:r>
           </a:p>
@@ -6622,7 +6705,7 @@
               <a:buNone/>
             </a:pPr>
             <a:r>
-              <a:rPr lang="en-US" altLang="en-US" sz="1200"/>
+              <a:rPr lang="en-US" altLang="en-US" sz="1200" dirty="0"/>
               <a:t>	C)  F, C, D, B, G, A, E </a:t>
             </a:r>
           </a:p>
@@ -6635,8 +6718,70 @@
               <a:buNone/>
             </a:pPr>
             <a:r>
-              <a:rPr lang="en-US" altLang="en-US" sz="1200"/>
+              <a:rPr lang="en-US" altLang="en-US" sz="1200" dirty="0"/>
               <a:t>	D)  a, b, and c are all breadth first traversals </a:t>
+            </a:r>
+          </a:p>
+          <a:p>
+            <a:pPr>
+              <a:spcBef>
+                <a:spcPct val="0"/>
+              </a:spcBef>
+              <a:buFontTx/>
+              <a:buNone/>
+            </a:pPr>
+            <a:r>
+              <a:rPr lang="en-US" altLang="en-US" sz="1200" dirty="0"/>
+              <a:t>Alphabetical order gets option A</a:t>
+            </a:r>
+          </a:p>
+          <a:p>
+            <a:pPr>
+              <a:spcBef>
+                <a:spcPct val="0"/>
+              </a:spcBef>
+              <a:buFontTx/>
+              <a:buNone/>
+            </a:pPr>
+            <a:r>
+              <a:rPr lang="en-US" altLang="en-US" sz="1200" dirty="0"/>
+              <a:t>Reverse alphabetical order gets FDCAEBG which isn’t an option</a:t>
+            </a:r>
+          </a:p>
+          <a:p>
+            <a:pPr>
+              <a:spcBef>
+                <a:spcPct val="0"/>
+              </a:spcBef>
+              <a:buFontTx/>
+              <a:buNone/>
+            </a:pPr>
+            <a:r>
+              <a:rPr lang="en-US" altLang="en-US" sz="1200" dirty="0"/>
+              <a:t>Option B cannot be correct since it repeats vertices</a:t>
+            </a:r>
+          </a:p>
+          <a:p>
+            <a:pPr>
+              <a:spcBef>
+                <a:spcPct val="0"/>
+              </a:spcBef>
+              <a:buFontTx/>
+              <a:buNone/>
+            </a:pPr>
+            <a:endParaRPr lang="en-US" altLang="en-US" sz="1200" dirty="0"/>
+          </a:p>
+          <a:p>
+            <a:pPr>
+              <a:spcBef>
+                <a:spcPct val="0"/>
+              </a:spcBef>
+              <a:buFontTx/>
+              <a:buNone/>
+            </a:pPr>
+            <a:r>
+              <a:rPr lang="en-US" altLang="en-US" sz="1200" dirty="0"/>
+              <a:t>ANSWER: A</a:t>
             </a:r>
           </a:p>
         </p:txBody>
@@ -6743,7 +6888,7 @@
         <p:spPr bwMode="auto">
           <a:xfrm>
             <a:off x="609600" y="3962400"/>
-            <a:ext cx="3911600" cy="274638"/>
+            <a:ext cx="3978525" cy="646331"/>
           </a:xfrm>
           <a:prstGeom prst="rect">
             <a:avLst/>
@@ -6899,16 +7044,16 @@
             </a:lvl9pPr>
           </a:lstStyle>
           <a:p>
-            <a:pPr>
+            <a:pPr marL="228600" indent="-228600">
               <a:spcBef>
                 <a:spcPct val="0"/>
               </a:spcBef>
               <a:buFontTx/>
-              <a:buNone/>
+              <a:buAutoNum type="arabicPeriod" startAt="5"/>
             </a:pPr>
             <a:r>
               <a:rPr lang="en-US" altLang="en-US" sz="1200" dirty="0"/>
-              <a:t>5.  Find the shortest </a:t>
+              <a:t>Find the shortest </a:t>
             </a:r>
             <a:r>
               <a:rPr lang="en-US" altLang="en-US" sz="1200" u="sng" dirty="0"/>
@@ -6918,6 +7063,25 @@
               <a:rPr lang="en-US" altLang="en-US" sz="1200" dirty="0"/>
               <a:t> from Atlanta to every other city</a:t>
             </a:r>
+          </a:p>
+          <a:p>
+            <a:pPr marL="228600" indent="-228600">
+              <a:spcBef>
+                <a:spcPct val="0"/>
+              </a:spcBef>
+              <a:buFontTx/>
+              <a:buAutoNum type="arabicPeriod" startAt="5"/>
+            </a:pPr>
+            <a:endParaRPr lang="en-US" altLang="en-US" sz="1200" dirty="0"/>
+          </a:p>
+          <a:p>
+            <a:pPr>
+              <a:spcBef>
+                <a:spcPct val="0"/>
+              </a:spcBef>
+              <a:buNone/>
+            </a:pPr>
+            <a:endParaRPr lang="en-US" altLang="en-US" sz="1200" dirty="0"/>
           </a:p>
         </p:txBody>
       </p:sp>
@@ -7216,6 +7380,62 @@
           </a:extLst>
         </p:spPr>
       </p:pic>
+      <p:sp>
+        <p:nvSpPr>
+          <p:cNvPr id="3" name="TextBox 2">
+            <a:extLst>
+              <a:ext uri="{FF2B5EF4-FFF2-40B4-BE49-F238E27FC236}">
+                <a16:creationId xmlns:a16="http://schemas.microsoft.com/office/drawing/2014/main" id="{60E27E15-F937-E0BF-2194-0CEB3BB18E34}"/>
+              </a:ext>
+            </a:extLst>
+          </p:cNvPr>
+          <p:cNvSpPr txBox="1"/>
+          <p:nvPr/>
+        </p:nvSpPr>
+        <p:spPr>
+          <a:xfrm>
+            <a:off x="609600" y="4114800"/>
+            <a:ext cx="2159566" cy="1200329"/>
+          </a:xfrm>
+          <a:prstGeom prst="rect">
+            <a:avLst/>
+          </a:prstGeom>
+          <a:noFill/>
+        </p:spPr>
+        <p:txBody>
+          <a:bodyPr wrap="none" rtlCol="0">
+            <a:spAutoFit/>
+          </a:bodyPr>
+          <a:lstStyle/>
+          <a:p>
+            <a:r>
+              <a:rPr lang="en-US" dirty="0"/>
+              <a:t>0, 2, 5, 1, 4, 3</a:t>
+            </a:r>
+          </a:p>
+          <a:p>
+            <a:r>
+              <a:rPr lang="en-US" dirty="0"/>
+              <a:t>0</a:t>
+            </a:r>
+            <a:r>
+              <a:rPr lang="en-US" dirty="0">
+                <a:sym typeface="Wingdings" panose="05000000000000000000" pitchFamily="2" charset="2"/>
+              </a:rPr>
+              <a:t>2513</a:t>
+            </a:r>
+          </a:p>
+          <a:p>
+            <a:r>
+              <a:rPr lang="en-US" dirty="0">
+                <a:sym typeface="Wingdings" panose="05000000000000000000" pitchFamily="2" charset="2"/>
+              </a:rPr>
+              <a:t>54</a:t>
+            </a:r>
+            <a:endParaRPr lang="en-US" dirty="0"/>
+          </a:p>
+        </p:txBody>
+      </p:sp>
     </p:spTree>
   </p:cSld>
   <p:clrMapOvr>
@@ -8645,6 +8865,41 @@
             <a:r>
               <a:rPr lang="en-US" altLang="en-US" sz="1350" dirty="0"/>
               <a:t>	Minneapolis/St. Paul as the source vertex</a:t>
+            </a:r>
+          </a:p>
+        </p:txBody>
+      </p:sp>
+      <p:sp>
+        <p:nvSpPr>
+          <p:cNvPr id="2" name="TextBox 1">
+            <a:extLst>
+              <a:ext uri="{FF2B5EF4-FFF2-40B4-BE49-F238E27FC236}">
+                <a16:creationId xmlns:a16="http://schemas.microsoft.com/office/drawing/2014/main" id="{25994F80-3CC1-0071-8D65-C78EA83447DB}"/>
+              </a:ext>
+            </a:extLst>
+          </p:cNvPr>
+          <p:cNvSpPr txBox="1"/>
+          <p:nvPr/>
+        </p:nvSpPr>
+        <p:spPr>
+          <a:xfrm>
+            <a:off x="1066800" y="6324600"/>
+            <a:ext cx="1596912" cy="461665"/>
+          </a:xfrm>
+          <a:prstGeom prst="rect">
+            <a:avLst/>
+          </a:prstGeom>
+          <a:noFill/>
+        </p:spPr>
+        <p:txBody>
+          <a:bodyPr wrap="none" rtlCol="0">
+            <a:spAutoFit/>
+          </a:bodyPr>
+          <a:lstStyle/>
+          <a:p>
+            <a:r>
+              <a:rPr lang="en-US" dirty="0"/>
+              <a:t>USE PRIM</a:t>
             </a:r>
           </a:p>
         </p:txBody>

</xml_diff>